<commit_message>
test: idempotency, concurrency, guardrail hardening
</commit_message>
<xml_diff>
--- a/artifacts/reports/sales_report_2026-09-01_2026-09-30.pptx
+++ b/artifacts/reports/sales_report_2026-09-01_2026-09-30.pptx
@@ -3431,33 +3431,9 @@
           </a:p>
         </p:txBody>
       </p:sp>
-      <p:pic>
-        <p:nvPicPr>
-          <p:cNvPr id="4" name="Picture 3" descr="image.png"/>
-          <p:cNvPicPr>
-            <a:picLocks noChangeAspect="1"/>
-          </p:cNvPicPr>
-          <p:nvPr/>
-        </p:nvPicPr>
-        <p:blipFill>
-          <a:blip r:embed="rId2"/>
-          <a:stretch>
-            <a:fillRect/>
-          </a:stretch>
-        </p:blipFill>
-        <p:spPr>
-          <a:xfrm>
-            <a:off x="2743200" y="914400"/>
-            <a:ext cx="3657600" cy="3888059"/>
-          </a:xfrm>
-          <a:prstGeom prst="rect">
-            <a:avLst/>
-          </a:prstGeom>
-        </p:spPr>
-      </p:pic>
-      <p:sp>
-        <p:nvSpPr>
-          <p:cNvPr id="5" name="TextBox 4"/>
+      <p:sp>
+        <p:nvSpPr>
+          <p:cNvPr id="4" name="TextBox 3"/>
           <p:cNvSpPr txBox="1"/>
           <p:nvPr/>
         </p:nvSpPr>
@@ -3478,7 +3454,7 @@
           <a:lstStyle/>
           <a:p>
             <a:r>
-              <a:t>Total: 10  |  Healthy: 10  |  Low Stock: 0</a:t>
+              <a:t>Total: 0  |  Healthy: 0  |  Low Stock: 0</a:t>
             </a:r>
           </a:p>
         </p:txBody>

</xml_diff>